<commit_message>
Cancha model/: area de 1 columna, arcos, objeto pickup con disparo y goles; elimina micrositios ajenos a la cancha CR7
- model/: linea de area reducida a 1 columna (J y espejo A), semicirculos
  en B4/I4, objeto pickup (balon) atrapable que se dispara con X 2 casillas
  hacia la linea de meta amarilla sumando 5 puntos por gol; puntaje de
  jugadores reiniciado a 0.
- Elimina las carpetas de micrositios institucionales ajenos a la cancha
  CR7 (pages/Senacegafe, senacol, sena sofia, betowa, Sennova, LMS) y
  actualiza el README.
- docs/reglas-cancha.md: nueva fuente normativa de reglas espaciales de
  la cancha.
</commit_message>
<xml_diff>
--- a/assets/img/CANCHA FUTBOL/Cancha.pptx
+++ b/assets/img/CANCHA FUTBOL/Cancha.pptx
@@ -6,6 +6,7 @@
   </p:sldMasterIdLst>
   <p:sldIdLst>
     <p:sldId id="256" r:id="rId2"/>
+    <p:sldId id="257" r:id="rId3"/>
   </p:sldIdLst>
   <p:sldSz cx="12192000" cy="6858000"/>
   <p:notesSz cx="6858000" cy="9144000"/>
@@ -104,6 +105,11 @@
       </a:defRPr>
     </a:lvl9pPr>
   </p:defaultTextStyle>
+  <p:extLst>
+    <p:ext uri="{EFAFB233-063F-42B5-8137-9DF3F51BA10A}">
+      <p15:sldGuideLst xmlns:p15="http://schemas.microsoft.com/office/powerpoint/2012/main"/>
+    </p:ext>
+  </p:extLst>
 </p:presentation>
 </file>
 
@@ -256,7 +262,7 @@
           <a:p>
             <a:fld id="{56A5B4E1-AA8D-4A0C-AFA1-DE2CFB32E99E}" type="datetimeFigureOut">
               <a:rPr lang="es-CO" smtClean="0"/>
-              <a:t>20/08/2026</a:t>
+              <a:t>21/08/2026</a:t>
             </a:fld>
             <a:endParaRPr lang="es-CO"/>
           </a:p>
@@ -456,7 +462,7 @@
           <a:p>
             <a:fld id="{56A5B4E1-AA8D-4A0C-AFA1-DE2CFB32E99E}" type="datetimeFigureOut">
               <a:rPr lang="es-CO" smtClean="0"/>
-              <a:t>20/08/2026</a:t>
+              <a:t>21/08/2026</a:t>
             </a:fld>
             <a:endParaRPr lang="es-CO"/>
           </a:p>
@@ -666,7 +672,7 @@
           <a:p>
             <a:fld id="{56A5B4E1-AA8D-4A0C-AFA1-DE2CFB32E99E}" type="datetimeFigureOut">
               <a:rPr lang="es-CO" smtClean="0"/>
-              <a:t>20/08/2026</a:t>
+              <a:t>21/08/2026</a:t>
             </a:fld>
             <a:endParaRPr lang="es-CO"/>
           </a:p>
@@ -866,7 +872,7 @@
           <a:p>
             <a:fld id="{56A5B4E1-AA8D-4A0C-AFA1-DE2CFB32E99E}" type="datetimeFigureOut">
               <a:rPr lang="es-CO" smtClean="0"/>
-              <a:t>20/08/2026</a:t>
+              <a:t>21/08/2026</a:t>
             </a:fld>
             <a:endParaRPr lang="es-CO"/>
           </a:p>
@@ -1142,7 +1148,7 @@
           <a:p>
             <a:fld id="{56A5B4E1-AA8D-4A0C-AFA1-DE2CFB32E99E}" type="datetimeFigureOut">
               <a:rPr lang="es-CO" smtClean="0"/>
-              <a:t>20/08/2026</a:t>
+              <a:t>21/08/2026</a:t>
             </a:fld>
             <a:endParaRPr lang="es-CO"/>
           </a:p>
@@ -1410,7 +1416,7 @@
           <a:p>
             <a:fld id="{56A5B4E1-AA8D-4A0C-AFA1-DE2CFB32E99E}" type="datetimeFigureOut">
               <a:rPr lang="es-CO" smtClean="0"/>
-              <a:t>20/08/2026</a:t>
+              <a:t>21/08/2026</a:t>
             </a:fld>
             <a:endParaRPr lang="es-CO"/>
           </a:p>
@@ -1825,7 +1831,7 @@
           <a:p>
             <a:fld id="{56A5B4E1-AA8D-4A0C-AFA1-DE2CFB32E99E}" type="datetimeFigureOut">
               <a:rPr lang="es-CO" smtClean="0"/>
-              <a:t>20/08/2026</a:t>
+              <a:t>21/08/2026</a:t>
             </a:fld>
             <a:endParaRPr lang="es-CO"/>
           </a:p>
@@ -1967,7 +1973,7 @@
           <a:p>
             <a:fld id="{56A5B4E1-AA8D-4A0C-AFA1-DE2CFB32E99E}" type="datetimeFigureOut">
               <a:rPr lang="es-CO" smtClean="0"/>
-              <a:t>20/08/2026</a:t>
+              <a:t>21/08/2026</a:t>
             </a:fld>
             <a:endParaRPr lang="es-CO"/>
           </a:p>
@@ -2080,7 +2086,7 @@
           <a:p>
             <a:fld id="{56A5B4E1-AA8D-4A0C-AFA1-DE2CFB32E99E}" type="datetimeFigureOut">
               <a:rPr lang="es-CO" smtClean="0"/>
-              <a:t>20/08/2026</a:t>
+              <a:t>21/08/2026</a:t>
             </a:fld>
             <a:endParaRPr lang="es-CO"/>
           </a:p>
@@ -2393,7 +2399,7 @@
           <a:p>
             <a:fld id="{56A5B4E1-AA8D-4A0C-AFA1-DE2CFB32E99E}" type="datetimeFigureOut">
               <a:rPr lang="es-CO" smtClean="0"/>
-              <a:t>20/08/2026</a:t>
+              <a:t>21/08/2026</a:t>
             </a:fld>
             <a:endParaRPr lang="es-CO"/>
           </a:p>
@@ -2682,7 +2688,7 @@
           <a:p>
             <a:fld id="{56A5B4E1-AA8D-4A0C-AFA1-DE2CFB32E99E}" type="datetimeFigureOut">
               <a:rPr lang="es-CO" smtClean="0"/>
-              <a:t>20/08/2026</a:t>
+              <a:t>21/08/2026</a:t>
             </a:fld>
             <a:endParaRPr lang="es-CO"/>
           </a:p>
@@ -2925,7 +2931,7 @@
           <a:p>
             <a:fld id="{56A5B4E1-AA8D-4A0C-AFA1-DE2CFB32E99E}" type="datetimeFigureOut">
               <a:rPr lang="es-CO" smtClean="0"/>
-              <a:t>20/08/2026</a:t>
+              <a:t>21/08/2026</a:t>
             </a:fld>
             <a:endParaRPr lang="es-CO"/>
           </a:p>
@@ -4126,6 +4132,434 @@
     <p:extLst>
       <p:ext uri="{BB962C8B-B14F-4D97-AF65-F5344CB8AC3E}">
         <p14:creationId xmlns:p14="http://schemas.microsoft.com/office/powerpoint/2010/main" val="1001252369"/>
+      </p:ext>
+    </p:extLst>
+  </p:cSld>
+  <p:clrMapOvr>
+    <a:masterClrMapping/>
+  </p:clrMapOvr>
+</p:sld>
+</file>
+
+<file path=ppt/slides/slide2.xml><?xml version="1.0" encoding="utf-8"?>
+<p:sld xmlns:a="http://schemas.openxmlformats.org/drawingml/2006/main" xmlns:r="http://schemas.openxmlformats.org/officeDocument/2006/relationships" xmlns:p="http://schemas.openxmlformats.org/presentationml/2006/main">
+  <p:cSld>
+    <p:spTree>
+      <p:nvGrpSpPr>
+        <p:cNvPr id="1" name=""/>
+        <p:cNvGrpSpPr/>
+        <p:nvPr/>
+      </p:nvGrpSpPr>
+      <p:grpSpPr>
+        <a:xfrm>
+          <a:off x="0" y="0"/>
+          <a:ext cx="0" cy="0"/>
+          <a:chOff x="0" y="0"/>
+          <a:chExt cx="0" cy="0"/>
+        </a:xfrm>
+      </p:grpSpPr>
+      <p:sp>
+        <p:nvSpPr>
+          <p:cNvPr id="2" name="Título 1">
+            <a:extLst>
+              <a:ext uri="{FF2B5EF4-FFF2-40B4-BE49-F238E27FC236}">
+                <a16:creationId xmlns:a16="http://schemas.microsoft.com/office/drawing/2014/main" id="{30E18615-156B-5468-4CD7-783E66286AAA}"/>
+              </a:ext>
+            </a:extLst>
+          </p:cNvPr>
+          <p:cNvSpPr>
+            <a:spLocks noGrp="1"/>
+          </p:cNvSpPr>
+          <p:nvPr>
+            <p:ph type="title"/>
+          </p:nvPr>
+        </p:nvSpPr>
+        <p:spPr/>
+        <p:txBody>
+          <a:bodyPr/>
+          <a:lstStyle/>
+          <a:p>
+            <a:endParaRPr lang="es-CO"/>
+          </a:p>
+        </p:txBody>
+      </p:sp>
+      <p:pic>
+        <p:nvPicPr>
+          <p:cNvPr id="8" name="Marcador de contenido 7">
+            <a:extLst>
+              <a:ext uri="{FF2B5EF4-FFF2-40B4-BE49-F238E27FC236}">
+                <a16:creationId xmlns:a16="http://schemas.microsoft.com/office/drawing/2014/main" id="{83D7DEAA-98DC-FED1-0136-BE6F07AD3109}"/>
+              </a:ext>
+            </a:extLst>
+          </p:cNvPr>
+          <p:cNvPicPr>
+            <a:picLocks noGrp="1" noChangeAspect="1"/>
+          </p:cNvPicPr>
+          <p:nvPr>
+            <p:ph idx="1"/>
+          </p:nvPr>
+        </p:nvPicPr>
+        <p:blipFill>
+          <a:blip r:embed="rId2">
+            <a:extLst>
+              <a:ext uri="{28A0092B-C50C-407E-A947-70E740481C1C}">
+                <a14:useLocalDpi xmlns:a14="http://schemas.microsoft.com/office/drawing/2010/main" val="0"/>
+              </a:ext>
+            </a:extLst>
+          </a:blip>
+          <a:stretch>
+            <a:fillRect/>
+          </a:stretch>
+        </p:blipFill>
+        <p:spPr>
+          <a:xfrm>
+            <a:off x="0" y="0"/>
+            <a:ext cx="12192000" cy="6861646"/>
+          </a:xfrm>
+          <a:prstGeom prst="rect">
+            <a:avLst/>
+          </a:prstGeom>
+        </p:spPr>
+      </p:pic>
+      <p:sp>
+        <p:nvSpPr>
+          <p:cNvPr id="10" name="Forma libre: forma 9">
+            <a:extLst>
+              <a:ext uri="{FF2B5EF4-FFF2-40B4-BE49-F238E27FC236}">
+                <a16:creationId xmlns:a16="http://schemas.microsoft.com/office/drawing/2014/main" id="{3B20FD3F-2E54-2A31-8302-2ED5036E8779}"/>
+              </a:ext>
+            </a:extLst>
+          </p:cNvPr>
+          <p:cNvSpPr/>
+          <p:nvPr/>
+        </p:nvSpPr>
+        <p:spPr>
+          <a:xfrm>
+            <a:off x="5456903" y="3008671"/>
+            <a:ext cx="693174" cy="486697"/>
+          </a:xfrm>
+          <a:custGeom>
+            <a:avLst/>
+            <a:gdLst>
+              <a:gd name="csX0" fmla="*/ 0 w 693174"/>
+              <a:gd name="csY0" fmla="*/ 486697 h 486697"/>
+              <a:gd name="csX1" fmla="*/ 693174 w 693174"/>
+              <a:gd name="csY1" fmla="*/ 457200 h 486697"/>
+              <a:gd name="csX2" fmla="*/ 648929 w 693174"/>
+              <a:gd name="csY2" fmla="*/ 44245 h 486697"/>
+              <a:gd name="csX3" fmla="*/ 58994 w 693174"/>
+              <a:gd name="csY3" fmla="*/ 0 h 486697"/>
+              <a:gd name="csX4" fmla="*/ 0 w 693174"/>
+              <a:gd name="csY4" fmla="*/ 486697 h 486697"/>
+            </a:gdLst>
+            <a:ahLst/>
+            <a:cxnLst>
+              <a:cxn ang="0">
+                <a:pos x="csX0" y="csY0"/>
+              </a:cxn>
+              <a:cxn ang="0">
+                <a:pos x="csX1" y="csY1"/>
+              </a:cxn>
+              <a:cxn ang="0">
+                <a:pos x="csX2" y="csY2"/>
+              </a:cxn>
+              <a:cxn ang="0">
+                <a:pos x="csX3" y="csY3"/>
+              </a:cxn>
+              <a:cxn ang="0">
+                <a:pos x="csX4" y="csY4"/>
+              </a:cxn>
+            </a:cxnLst>
+            <a:rect l="l" t="t" r="r" b="b"/>
+            <a:pathLst>
+              <a:path w="693174" h="486697">
+                <a:moveTo>
+                  <a:pt x="0" y="486697"/>
+                </a:moveTo>
+                <a:lnTo>
+                  <a:pt x="693174" y="457200"/>
+                </a:lnTo>
+                <a:lnTo>
+                  <a:pt x="648929" y="44245"/>
+                </a:lnTo>
+                <a:lnTo>
+                  <a:pt x="58994" y="0"/>
+                </a:lnTo>
+                <a:lnTo>
+                  <a:pt x="0" y="486697"/>
+                </a:lnTo>
+                <a:close/>
+              </a:path>
+            </a:pathLst>
+          </a:custGeom>
+          <a:solidFill>
+            <a:schemeClr val="accent2"/>
+          </a:solidFill>
+          <a:ln>
+            <a:noFill/>
+          </a:ln>
+        </p:spPr>
+        <p:style>
+          <a:lnRef idx="2">
+            <a:schemeClr val="accent1">
+              <a:shade val="15000"/>
+            </a:schemeClr>
+          </a:lnRef>
+          <a:fillRef idx="1">
+            <a:schemeClr val="accent1"/>
+          </a:fillRef>
+          <a:effectRef idx="0">
+            <a:schemeClr val="accent1"/>
+          </a:effectRef>
+          <a:fontRef idx="minor">
+            <a:schemeClr val="lt1"/>
+          </a:fontRef>
+        </p:style>
+        <p:txBody>
+          <a:bodyPr rtlCol="0" anchor="ctr"/>
+          <a:lstStyle/>
+          <a:p>
+            <a:pPr algn="ctr"/>
+            <a:endParaRPr lang="es-CO"/>
+          </a:p>
+        </p:txBody>
+      </p:sp>
+      <p:sp>
+        <p:nvSpPr>
+          <p:cNvPr id="11" name="Flecha: hacia abajo 10">
+            <a:extLst>
+              <a:ext uri="{FF2B5EF4-FFF2-40B4-BE49-F238E27FC236}">
+                <a16:creationId xmlns:a16="http://schemas.microsoft.com/office/drawing/2014/main" id="{DD35F3AF-0E4E-B03B-54E0-C4CC71DD88A7}"/>
+              </a:ext>
+            </a:extLst>
+          </p:cNvPr>
+          <p:cNvSpPr/>
+          <p:nvPr/>
+        </p:nvSpPr>
+        <p:spPr>
+          <a:xfrm>
+            <a:off x="5565057" y="3649360"/>
+            <a:ext cx="476865" cy="486697"/>
+          </a:xfrm>
+          <a:prstGeom prst="downArrow">
+            <a:avLst/>
+          </a:prstGeom>
+          <a:solidFill>
+            <a:srgbClr val="FFFF00"/>
+          </a:solidFill>
+        </p:spPr>
+        <p:style>
+          <a:lnRef idx="2">
+            <a:schemeClr val="accent1">
+              <a:shade val="15000"/>
+            </a:schemeClr>
+          </a:lnRef>
+          <a:fillRef idx="1">
+            <a:schemeClr val="accent1"/>
+          </a:fillRef>
+          <a:effectRef idx="0">
+            <a:schemeClr val="accent1"/>
+          </a:effectRef>
+          <a:fontRef idx="minor">
+            <a:schemeClr val="lt1"/>
+          </a:fontRef>
+        </p:style>
+        <p:txBody>
+          <a:bodyPr rtlCol="0" anchor="ctr"/>
+          <a:lstStyle/>
+          <a:p>
+            <a:pPr algn="ctr"/>
+            <a:endParaRPr lang="es-CO"/>
+          </a:p>
+        </p:txBody>
+      </p:sp>
+      <p:sp>
+        <p:nvSpPr>
+          <p:cNvPr id="12" name="Flecha: hacia abajo 11">
+            <a:extLst>
+              <a:ext uri="{FF2B5EF4-FFF2-40B4-BE49-F238E27FC236}">
+                <a16:creationId xmlns:a16="http://schemas.microsoft.com/office/drawing/2014/main" id="{B8EB2F96-E7CC-F6D2-41D6-D9559DE4C867}"/>
+              </a:ext>
+            </a:extLst>
+          </p:cNvPr>
+          <p:cNvSpPr/>
+          <p:nvPr/>
+        </p:nvSpPr>
+        <p:spPr>
+          <a:xfrm rot="10800000">
+            <a:off x="5619135" y="1662859"/>
+            <a:ext cx="476865" cy="486697"/>
+          </a:xfrm>
+          <a:prstGeom prst="downArrow">
+            <a:avLst/>
+          </a:prstGeom>
+          <a:solidFill>
+            <a:srgbClr val="FFFF00"/>
+          </a:solidFill>
+        </p:spPr>
+        <p:style>
+          <a:lnRef idx="2">
+            <a:schemeClr val="accent1">
+              <a:shade val="15000"/>
+            </a:schemeClr>
+          </a:lnRef>
+          <a:fillRef idx="1">
+            <a:schemeClr val="accent1"/>
+          </a:fillRef>
+          <a:effectRef idx="0">
+            <a:schemeClr val="accent1"/>
+          </a:effectRef>
+          <a:fontRef idx="minor">
+            <a:schemeClr val="lt1"/>
+          </a:fontRef>
+        </p:style>
+        <p:txBody>
+          <a:bodyPr rtlCol="0" anchor="ctr"/>
+          <a:lstStyle/>
+          <a:p>
+            <a:pPr algn="ctr"/>
+            <a:endParaRPr lang="es-CO" dirty="0"/>
+          </a:p>
+        </p:txBody>
+      </p:sp>
+      <p:sp>
+        <p:nvSpPr>
+          <p:cNvPr id="13" name="Flecha: hacia abajo 12">
+            <a:extLst>
+              <a:ext uri="{FF2B5EF4-FFF2-40B4-BE49-F238E27FC236}">
+                <a16:creationId xmlns:a16="http://schemas.microsoft.com/office/drawing/2014/main" id="{692525AC-8DF9-43EB-D85B-D99D93171EB1}"/>
+              </a:ext>
+            </a:extLst>
+          </p:cNvPr>
+          <p:cNvSpPr/>
+          <p:nvPr/>
+        </p:nvSpPr>
+        <p:spPr>
+          <a:xfrm rot="5400000">
+            <a:off x="4783394" y="3008670"/>
+            <a:ext cx="476865" cy="486697"/>
+          </a:xfrm>
+          <a:prstGeom prst="downArrow">
+            <a:avLst/>
+          </a:prstGeom>
+          <a:solidFill>
+            <a:srgbClr val="FFFF00"/>
+          </a:solidFill>
+        </p:spPr>
+        <p:style>
+          <a:lnRef idx="2">
+            <a:schemeClr val="accent1">
+              <a:shade val="15000"/>
+            </a:schemeClr>
+          </a:lnRef>
+          <a:fillRef idx="1">
+            <a:schemeClr val="accent1"/>
+          </a:fillRef>
+          <a:effectRef idx="0">
+            <a:schemeClr val="accent1"/>
+          </a:effectRef>
+          <a:fontRef idx="minor">
+            <a:schemeClr val="lt1"/>
+          </a:fontRef>
+        </p:style>
+        <p:txBody>
+          <a:bodyPr rtlCol="0" anchor="ctr"/>
+          <a:lstStyle/>
+          <a:p>
+            <a:pPr algn="ctr"/>
+            <a:endParaRPr lang="es-CO"/>
+          </a:p>
+        </p:txBody>
+      </p:sp>
+      <p:sp>
+        <p:nvSpPr>
+          <p:cNvPr id="14" name="Flecha: hacia abajo 13">
+            <a:extLst>
+              <a:ext uri="{FF2B5EF4-FFF2-40B4-BE49-F238E27FC236}">
+                <a16:creationId xmlns:a16="http://schemas.microsoft.com/office/drawing/2014/main" id="{057B419B-839A-7F78-A0EE-FA8D39AD5C9F}"/>
+              </a:ext>
+            </a:extLst>
+          </p:cNvPr>
+          <p:cNvSpPr/>
+          <p:nvPr/>
+        </p:nvSpPr>
+        <p:spPr>
+          <a:xfrm rot="16200000">
+            <a:off x="6346721" y="3028335"/>
+            <a:ext cx="476865" cy="486697"/>
+          </a:xfrm>
+          <a:prstGeom prst="downArrow">
+            <a:avLst/>
+          </a:prstGeom>
+          <a:solidFill>
+            <a:srgbClr val="FFFF00"/>
+          </a:solidFill>
+        </p:spPr>
+        <p:style>
+          <a:lnRef idx="2">
+            <a:schemeClr val="accent1">
+              <a:shade val="15000"/>
+            </a:schemeClr>
+          </a:lnRef>
+          <a:fillRef idx="1">
+            <a:schemeClr val="accent1"/>
+          </a:fillRef>
+          <a:effectRef idx="0">
+            <a:schemeClr val="accent1"/>
+          </a:effectRef>
+          <a:fontRef idx="minor">
+            <a:schemeClr val="lt1"/>
+          </a:fontRef>
+        </p:style>
+        <p:txBody>
+          <a:bodyPr rtlCol="0" anchor="ctr"/>
+          <a:lstStyle/>
+          <a:p>
+            <a:pPr algn="ctr"/>
+            <a:endParaRPr lang="es-CO"/>
+          </a:p>
+        </p:txBody>
+      </p:sp>
+      <p:pic>
+        <p:nvPicPr>
+          <p:cNvPr id="16" name="Imagen 15">
+            <a:extLst>
+              <a:ext uri="{FF2B5EF4-FFF2-40B4-BE49-F238E27FC236}">
+                <a16:creationId xmlns:a16="http://schemas.microsoft.com/office/drawing/2014/main" id="{D11A0B0B-13D5-32EE-A782-D7044535442C}"/>
+              </a:ext>
+            </a:extLst>
+          </p:cNvPr>
+          <p:cNvPicPr>
+            <a:picLocks noChangeAspect="1"/>
+          </p:cNvPicPr>
+          <p:nvPr/>
+        </p:nvPicPr>
+        <p:blipFill>
+          <a:blip r:embed="rId3">
+            <a:extLst>
+              <a:ext uri="{28A0092B-C50C-407E-A947-70E740481C1C}">
+                <a14:useLocalDpi xmlns:a14="http://schemas.microsoft.com/office/drawing/2010/main" val="0"/>
+              </a:ext>
+            </a:extLst>
+          </a:blip>
+          <a:stretch>
+            <a:fillRect/>
+          </a:stretch>
+        </p:blipFill>
+        <p:spPr>
+          <a:xfrm>
+            <a:off x="5142499" y="2092802"/>
+            <a:ext cx="1321979" cy="1417314"/>
+          </a:xfrm>
+          <a:prstGeom prst="rect">
+            <a:avLst/>
+          </a:prstGeom>
+        </p:spPr>
+      </p:pic>
+    </p:spTree>
+    <p:extLst>
+      <p:ext uri="{BB962C8B-B14F-4D97-AF65-F5344CB8AC3E}">
+        <p14:creationId xmlns:p14="http://schemas.microsoft.com/office/powerpoint/2010/main" val="1042239406"/>
       </p:ext>
     </p:extLst>
   </p:cSld>

</xml_diff>